<commit_message>
Enxuga a narração do curso em 84% e leva o detalhe para os slides
Narração por cena em audio/narracao/mXX.json (37 mil caracteres, 5 lotes,
~41 min de voz, contra 233 mil): a voz explica o porquê; listas, números e
tabelas ficam na tela. Laboratórios viram passo a passo escrito com telas
reais, sem áudio; resumos e encerramentos não são narrados. Slides ganham
faixa explicativa e teste rápido de múltipla escolha com gabarito por
módulo. A narração completa segue disponível com NARRACAO_COMPLETA=1.

Co-Authored-By: Claude Opus 5.5 <noreply@anthropic.com>
</commit_message>
<xml_diff>
--- a/docs/curso/slides/m12-projeto-final.pptx
+++ b/docs/curso/slides/m12-projeto-final.pptx
@@ -875,7 +875,7 @@
           <a:p>
             <a:r>
               <a:rPr lang="en-US" dirty="0"/>
-              <a:t>O que faz este projeto ser nota máxima? Os números batem entre o laboratório e os documentos. O comentário analisa, em vez de só descrever. Os riscos são honestos, incluindo os que preocupam. A linguagem é a correta — participação, gestão, economia calculada. E tudo é aplicável: este plano poderia ser apresentado amanhã a um investidor.</a:t>
+              <a:t>O que faz um projeto nota máxima: números que batem entre o laboratório e os documentos, análise em vez de descrição, riscos honestos e linguagem correta.</a:t>
             </a:r>
             <a:endParaRPr lang="en-US" dirty="0"/>
           </a:p>
@@ -963,8 +963,8 @@
           <a:p>
             <a:r>
               <a:rPr lang="en-US" dirty="0"/>
-              <a:t>Esta é a Solaris no laboratório, já com a marca dela. Duas usinas, com ocupação de noventa e quatro e noventa e seis por cento. Vinte e quatro clientes, entre empresas e residências; abra qualquer um e está tudo lá: unidade consumidora, proposta, contrato, vínculo e acesso ao portal. Três meses de faturas, todas aprovadas, com observações nas que tiveram pendência. Três meses de cobranças, com um ajuste justificado e uma vencida tratada com reemissão. E os alertas, sem nenhum crítico.
-Agora, os documentos. O plano em uma página, com os nove blocos. A conta do negócio, com os cenários de 2026 a 2029: repare que a Solaris mostra o cenário pessimista e o que faria se ele acontecesse. O relatório executivo do trimestre, com os doze indicadores e um comentário que explica o que aconteceu — por exemplo, a ocupação da usina dois caiu no mês dois por causa de duas saídas, e foi recomposta no mês três com clientes da fila. O relatório do produtor, de uma página. Os relatórios de economia. E o SOP, a régua de cobrança e a matriz de riscos, curtos e aplicáveis.</a:t>
+              <a:t>No laboratório: duas usinas bem ocupadas, vinte e quatro clientes, três meses fechados e nenhum alerta crítico.
+Nos documentos: plano, conta com cenários, relatório do trimestre, relatórios de produtor e de economia, procedimento padrão, régua e riscos.</a:t>
             </a:r>
             <a:endParaRPr lang="en-US" dirty="0"/>
           </a:p>
@@ -1228,7 +1228,7 @@
           <a:p>
             <a:r>
               <a:rPr lang="en-US" dirty="0"/>
-              <a:t>Se você vai tirar a empresa do papel, um plano para os primeiros noventa dias. Nos primeiros trinta: valide a sua conta com os números reais da sua distribuidora, contrate o advogado e o contador e converse com pelo menos cinco produtores. Do dia trinta e um ao sessenta: feche a primeira usina, com due diligence e contrato, monte a estrutura jurídica e configure a plataforma com a sua marca. Do sessenta e um ao noventa: faça a pré-venda, com data honesta, conquiste os primeiros trinta clientes, envie o rateio e rode o primeiro ciclo. E, se você já tem uma empresa solar, comece pela sua base de orçamentos perdidos.</a:t>
+              <a:t>Para tirar a empresa do papel, siga o plano dos noventa dias da tela: validar a conta, fechar a primeira usina e conquistar os primeiros clientes.</a:t>
             </a:r>
             <a:endParaRPr lang="en-US" dirty="0"/>
           </a:p>
@@ -1316,7 +1316,7 @@
           <a:p>
             <a:r>
               <a:rPr lang="en-US" dirty="0"/>
-              <a:t>Você não termina o curso sozinho. Continue na comunidade de ex-alunos, onde empreendedores de todo o país trocam experiências. Acompanhe as atualizações regulatórias semestrais, incluídas no seu acesso, especialmente as regras do Fio B a partir de 2029 e a reforma tributária. E, quando for operar de verdade, conte com a plataforma que você usou no curso, com condição especial para alunos, e com a implantação assistida, se quiser acompanhamento nos primeiros meses.</a:t>
+              <a:t>Continue na comunidade e acompanhe as atualizações regulatórias.</a:t>
             </a:r>
             <a:endParaRPr lang="en-US" dirty="0"/>
           </a:p>
@@ -1580,7 +1580,7 @@
           <a:p>
             <a:r>
               <a:rPr lang="en-US" dirty="0"/>
-              <a:t>No laboratório, a sua empresa precisa ter: a identidade visual aplicada; duas usinas — a do módulo 4 e uma nova —, cada uma com produtor, proposta e três meses de geração; mais de vinte clientes, misturando empresas e residências, cada um com unidade consumidora, proposta, contrato, vínculo e convite; ocupação entre noventa e noventa e oito por cento em cada usina, sem nenhum cliente com vinte e cinco por cento ou mais; três meses de faturas revisadas e aprovadas, com as pendências resolvidas e justificadas; três meses de cobranças, emitidas e pagas, com pelo menos um ajuste e uma cobrança vencida tratada; e os alertas críticos zerados no fechamento de cada mês. O laboratório tem o checkpoint do módulo 9 para quem precisar de uma base.</a:t>
+              <a:t>No laboratório, a sua empresa precisa ter tudo o que está na lista da tela.</a:t>
             </a:r>
             <a:endParaRPr lang="en-US" dirty="0"/>
           </a:p>
@@ -1668,7 +1668,7 @@
           <a:p>
             <a:r>
               <a:rPr lang="en-US" dirty="0"/>
-              <a:t>Em documento, entregue: o plano de negócio em uma página; a conta do negócio, com os cenários de 2026 a 2028 e 2029; o relatório executivo do trimestre, com os doze indicadores nos três meses e um comentário; o relatório de um produtor e três relatórios de economia de clientes; o SOP, a régua de cobrança e a matriz de riscos. E, na turma com acompanhamento, um vídeo de até cinco minutos apresentando a sua empresa, como se fosse para um investidor.</a:t>
+              <a:t>Em documento, entregue os itens da tela.</a:t>
             </a:r>
             <a:endParaRPr lang="en-US" dirty="0"/>
           </a:p>
@@ -1756,7 +1756,7 @@
           <a:p>
             <a:r>
               <a:rPr lang="en-US" dirty="0"/>
-              <a:t>Organize em duas semanas. Na primeira, o laboratório: segunda usina, clientes novos e o terceiro mês de operação. Na segunda, os documentos: relatórios, plano, vídeo, e uma revisão final usando a rubrica, que é o assunto da próxima aula. Use a comunidade: é permitido — e incentivado — trocar ideias com os colegas, desde que cada um entregue a própria empresa.</a:t>
+              <a:t>Organize em duas semanas: primeiro o laboratório, depois os documentos e a revisão pela rubrica.</a:t>
             </a:r>
             <a:endParaRPr lang="en-US" dirty="0"/>
           </a:p>
@@ -1932,7 +1932,7 @@
           <a:p>
             <a:r>
               <a:rPr lang="en-US" dirty="0"/>
-              <a:t>São cinco critérios. O primeiro, com trinta por cento, é a operação no laboratório: tudo o que está no checklist existe e está correto — usinas, clientes, ocupação, faturas, cobranças, alertas. O segundo, com vinte por cento, é a conta do negócio: os números são coerentes, têm origem e consideram os cenários do Fio B. O terceiro, com vinte, são os indicadores e relatórios: os números batem com o laboratório e o comentário mostra análise, não só descrição. O quarto, com vinte, é a gestão: SOP, régua de cobrança, matriz de riscos e plano em uma página, aplicáveis à vida real. E o quinto, com dez, é a comunicação: clareza, a linguagem correta — participação, gestão, sem "venda de energia" — e a apresentação.</a:t>
+              <a:t>O maior peso é a operação no laboratório. Nos documentos, vale a coerência dos números, a análise e a linguagem correta.</a:t>
             </a:r>
             <a:endParaRPr lang="en-US" dirty="0"/>
           </a:p>
@@ -2020,7 +2020,7 @@
           <a:p>
             <a:r>
               <a:rPr lang="en-US" dirty="0"/>
-              <a:t>Com setenta por cento ou mais, você é aprovado e recebe o certificado. Com noventa ou mais, o certificado sai com distinção, e o seu projeto pode ser convidado para a vitrine da comunidade. Abaixo de setenta, você recebe uma devolutiva detalhada e tem direito a uma nova entrega. No autoestudo, a avaliação é feita por você mesmo, com a rubrica e um checklist automático, e o certificado de conclusão exige os quizzes e a autoavaliação.</a:t>
+              <a:t>Setenta por cento aprova; noventa, com distinção.</a:t>
             </a:r>
             <a:endParaRPr lang="en-US" dirty="0"/>
           </a:p>
@@ -3191,11 +3191,11 @@
         <p:spPr>
           <a:xfrm>
             <a:off x="548640" y="1325880"/>
-            <a:ext cx="3544824" cy="2331720"/>
+            <a:ext cx="3544824" cy="1874520"/>
           </a:xfrm>
           <a:prstGeom prst="roundRect">
             <a:avLst>
-              <a:gd name="adj" fmla="val 3137"/>
+              <a:gd name="adj" fmla="val 3902"/>
             </a:avLst>
           </a:prstGeom>
           <a:solidFill>
@@ -3284,7 +3284,7 @@
         <p:spPr>
           <a:xfrm>
             <a:off x="1325880" y="1435608"/>
-            <a:ext cx="2630424" cy="2112264"/>
+            <a:ext cx="2630424" cy="1655064"/>
           </a:xfrm>
           <a:prstGeom prst="rect">
             <a:avLst/>
@@ -3325,11 +3325,11 @@
         <p:spPr>
           <a:xfrm>
             <a:off x="4322064" y="1325880"/>
-            <a:ext cx="3544824" cy="2331720"/>
+            <a:ext cx="3544824" cy="1874520"/>
           </a:xfrm>
           <a:prstGeom prst="roundRect">
             <a:avLst>
-              <a:gd name="adj" fmla="val 3137"/>
+              <a:gd name="adj" fmla="val 3902"/>
             </a:avLst>
           </a:prstGeom>
           <a:solidFill>
@@ -3418,7 +3418,7 @@
         <p:spPr>
           <a:xfrm>
             <a:off x="5099304" y="1435608"/>
-            <a:ext cx="2630424" cy="2112264"/>
+            <a:ext cx="2630424" cy="1655064"/>
           </a:xfrm>
           <a:prstGeom prst="rect">
             <a:avLst/>
@@ -3459,11 +3459,11 @@
         <p:spPr>
           <a:xfrm>
             <a:off x="8095488" y="1325880"/>
-            <a:ext cx="3544824" cy="2331720"/>
+            <a:ext cx="3544824" cy="1874520"/>
           </a:xfrm>
           <a:prstGeom prst="roundRect">
             <a:avLst>
-              <a:gd name="adj" fmla="val 3137"/>
+              <a:gd name="adj" fmla="val 3902"/>
             </a:avLst>
           </a:prstGeom>
           <a:solidFill>
@@ -3552,7 +3552,7 @@
         <p:spPr>
           <a:xfrm>
             <a:off x="8872728" y="1435608"/>
-            <a:ext cx="2630424" cy="2112264"/>
+            <a:ext cx="2630424" cy="1655064"/>
           </a:xfrm>
           <a:prstGeom prst="rect">
             <a:avLst/>
@@ -3592,12 +3592,12 @@
         </p:nvSpPr>
         <p:spPr>
           <a:xfrm>
-            <a:off x="548640" y="3886200"/>
-            <a:ext cx="3544824" cy="2331720"/>
+            <a:off x="548640" y="3429000"/>
+            <a:ext cx="3544824" cy="1874520"/>
           </a:xfrm>
           <a:prstGeom prst="roundRect">
             <a:avLst>
-              <a:gd name="adj" fmla="val 3137"/>
+              <a:gd name="adj" fmla="val 3902"/>
             </a:avLst>
           </a:prstGeom>
           <a:solidFill>
@@ -3626,7 +3626,7 @@
         </p:nvSpPr>
         <p:spPr>
           <a:xfrm>
-            <a:off x="731520" y="4069080"/>
+            <a:off x="731520" y="3611880"/>
             <a:ext cx="457200" cy="457200"/>
           </a:xfrm>
           <a:prstGeom prst="ellipse">
@@ -3646,7 +3646,7 @@
         </p:nvSpPr>
         <p:spPr>
           <a:xfrm>
-            <a:off x="731520" y="4069080"/>
+            <a:off x="731520" y="3611880"/>
             <a:ext cx="457200" cy="457200"/>
           </a:xfrm>
           <a:prstGeom prst="rect">
@@ -3685,8 +3685,8 @@
         </p:nvSpPr>
         <p:spPr>
           <a:xfrm>
-            <a:off x="1325880" y="3995928"/>
-            <a:ext cx="2630424" cy="2112264"/>
+            <a:off x="1325880" y="3538728"/>
+            <a:ext cx="2630424" cy="1655064"/>
           </a:xfrm>
           <a:prstGeom prst="rect">
             <a:avLst/>
@@ -3726,12 +3726,12 @@
         </p:nvSpPr>
         <p:spPr>
           <a:xfrm>
-            <a:off x="4322064" y="3886200"/>
-            <a:ext cx="3544824" cy="2331720"/>
+            <a:off x="4322064" y="3429000"/>
+            <a:ext cx="3544824" cy="1874520"/>
           </a:xfrm>
           <a:prstGeom prst="roundRect">
             <a:avLst>
-              <a:gd name="adj" fmla="val 3137"/>
+              <a:gd name="adj" fmla="val 3902"/>
             </a:avLst>
           </a:prstGeom>
           <a:solidFill>
@@ -3760,7 +3760,7 @@
         </p:nvSpPr>
         <p:spPr>
           <a:xfrm>
-            <a:off x="4504944" y="4069080"/>
+            <a:off x="4504944" y="3611880"/>
             <a:ext cx="457200" cy="457200"/>
           </a:xfrm>
           <a:prstGeom prst="ellipse">
@@ -3780,7 +3780,7 @@
         </p:nvSpPr>
         <p:spPr>
           <a:xfrm>
-            <a:off x="4504944" y="4069080"/>
+            <a:off x="4504944" y="3611880"/>
             <a:ext cx="457200" cy="457200"/>
           </a:xfrm>
           <a:prstGeom prst="rect">
@@ -3819,8 +3819,8 @@
         </p:nvSpPr>
         <p:spPr>
           <a:xfrm>
-            <a:off x="5099304" y="3995928"/>
-            <a:ext cx="2630424" cy="2112264"/>
+            <a:off x="5099304" y="3538728"/>
+            <a:ext cx="2630424" cy="1655064"/>
           </a:xfrm>
           <a:prstGeom prst="rect">
             <a:avLst/>
@@ -3849,6 +3849,92 @@
               <a:t>tudo aplicável à vida real</a:t>
             </a:r>
             <a:endParaRPr lang="en-US" sz="1800" dirty="0"/>
+          </a:p>
+        </p:txBody>
+      </p:sp>
+      <p:sp>
+        <p:nvSpPr>
+          <p:cNvPr id="29" name="Shape 26"/>
+          <p:cNvSpPr/>
+          <p:nvPr/>
+        </p:nvSpPr>
+        <p:spPr>
+          <a:xfrm>
+            <a:off x="548640" y="5413248"/>
+            <a:ext cx="11091672" cy="868680"/>
+          </a:xfrm>
+          <a:prstGeom prst="roundRect">
+            <a:avLst>
+              <a:gd name="adj" fmla="val 8421"/>
+            </a:avLst>
+          </a:prstGeom>
+          <a:solidFill>
+            <a:srgbClr val="EEF3FA"/>
+          </a:solidFill>
+          <a:ln w="6350">
+            <a:solidFill>
+              <a:srgbClr val="D8E0EC"/>
+            </a:solidFill>
+            <a:prstDash val="solid"/>
+          </a:ln>
+        </p:spPr>
+      </p:sp>
+      <p:sp>
+        <p:nvSpPr>
+          <p:cNvPr id="30" name="Shape 27"/>
+          <p:cNvSpPr/>
+          <p:nvPr/>
+        </p:nvSpPr>
+        <p:spPr>
+          <a:xfrm>
+            <a:off x="548640" y="5413248"/>
+            <a:ext cx="91440" cy="868680"/>
+          </a:xfrm>
+          <a:prstGeom prst="rect">
+            <a:avLst/>
+          </a:prstGeom>
+          <a:solidFill>
+            <a:srgbClr val="F7A23B"/>
+          </a:solidFill>
+          <a:ln/>
+        </p:spPr>
+      </p:sp>
+      <p:sp>
+        <p:nvSpPr>
+          <p:cNvPr id="31" name="Text 28"/>
+          <p:cNvSpPr/>
+          <p:nvPr/>
+        </p:nvSpPr>
+        <p:spPr>
+          <a:xfrm>
+            <a:off x="777240" y="5458968"/>
+            <a:ext cx="10744200" cy="777240"/>
+          </a:xfrm>
+          <a:prstGeom prst="rect">
+            <a:avLst/>
+          </a:prstGeom>
+          <a:noFill/>
+          <a:ln/>
+        </p:spPr>
+        <p:txBody>
+          <a:bodyPr wrap="square" rtlCol="0" anchor="ctr"/>
+          <a:lstStyle/>
+          <a:p>
+            <a:pPr indent="0" marL="0">
+              <a:buNone/>
+            </a:pPr>
+            <a:r>
+              <a:rPr lang="en-US" sz="1500" dirty="0">
+                <a:solidFill>
+                  <a:srgbClr val="1F2937"/>
+                </a:solidFill>
+                <a:latin typeface="Arial" pitchFamily="34" charset="0"/>
+                <a:ea typeface="Arial" pitchFamily="34" charset="-122"/>
+                <a:cs typeface="Arial" pitchFamily="34" charset="-120"/>
+              </a:rPr>
+              <a:t>O que faz um projeto nota máxima: números que batem entre o laboratório e os documentos, análise em vez de descrição, riscos honestos e linguagem correta.</a:t>
+            </a:r>
+            <a:endParaRPr lang="en-US" sz="1500" dirty="0"/>
           </a:p>
         </p:txBody>
       </p:sp>
@@ -4325,7 +4411,7 @@
                 <a:ea typeface="Arial" pitchFamily="34" charset="-122"/>
                 <a:cs typeface="Arial" pitchFamily="34" charset="-120"/>
               </a:rPr>
-              <a:t>2 usinas (94% e 96%) · 24 clientes · 3 meses: faturas aprovadas, cobranças pagas · zero críticos</a:t>
+              <a:t>No laboratório: duas usinas bem ocupadas, vinte e quatro clientes, três meses fechados e nenhum alerta crítico.</a:t>
             </a:r>
             <a:endParaRPr lang="en-US" sz="1500" dirty="0"/>
           </a:p>
@@ -4376,7 +4462,7 @@
                 <a:ea typeface="Arial" pitchFamily="34" charset="-122"/>
                 <a:cs typeface="Arial" pitchFamily="34" charset="-120"/>
               </a:rPr>
-              <a:t>Plano · conta com cenários · relatório do trimestre · produtor · economia · SOP · régua · riscos</a:t>
+              <a:t>Nos documentos: plano, conta com cenários, relatório do trimestre, relatórios de produtor e de economia, procedimento padrão, régua e riscos.</a:t>
             </a:r>
             <a:endParaRPr lang="en-US" sz="1500" dirty="0"/>
           </a:p>
@@ -5443,7 +5529,7 @@
         <p:spPr>
           <a:xfrm>
             <a:off x="548640" y="1325880"/>
-            <a:ext cx="11155680" cy="4937760"/>
+            <a:ext cx="11155680" cy="3977640"/>
           </a:xfrm>
           <a:prstGeom prst="rect">
             <a:avLst/>
@@ -5518,6 +5604,92 @@
               <a:t>Dias 61–90: pré-venda com data honesta · primeiros 30 clientes · rateio · primeiro ciclo</a:t>
             </a:r>
             <a:endParaRPr lang="en-US" sz="1400" dirty="0"/>
+          </a:p>
+        </p:txBody>
+      </p:sp>
+      <p:sp>
+        <p:nvSpPr>
+          <p:cNvPr id="10" name="Shape 7"/>
+          <p:cNvSpPr/>
+          <p:nvPr/>
+        </p:nvSpPr>
+        <p:spPr>
+          <a:xfrm>
+            <a:off x="548640" y="5413248"/>
+            <a:ext cx="11091672" cy="868680"/>
+          </a:xfrm>
+          <a:prstGeom prst="roundRect">
+            <a:avLst>
+              <a:gd name="adj" fmla="val 8421"/>
+            </a:avLst>
+          </a:prstGeom>
+          <a:solidFill>
+            <a:srgbClr val="EEF3FA"/>
+          </a:solidFill>
+          <a:ln w="6350">
+            <a:solidFill>
+              <a:srgbClr val="D8E0EC"/>
+            </a:solidFill>
+            <a:prstDash val="solid"/>
+          </a:ln>
+        </p:spPr>
+      </p:sp>
+      <p:sp>
+        <p:nvSpPr>
+          <p:cNvPr id="11" name="Shape 8"/>
+          <p:cNvSpPr/>
+          <p:nvPr/>
+        </p:nvSpPr>
+        <p:spPr>
+          <a:xfrm>
+            <a:off x="548640" y="5413248"/>
+            <a:ext cx="91440" cy="868680"/>
+          </a:xfrm>
+          <a:prstGeom prst="rect">
+            <a:avLst/>
+          </a:prstGeom>
+          <a:solidFill>
+            <a:srgbClr val="F7A23B"/>
+          </a:solidFill>
+          <a:ln/>
+        </p:spPr>
+      </p:sp>
+      <p:sp>
+        <p:nvSpPr>
+          <p:cNvPr id="12" name="Text 9"/>
+          <p:cNvSpPr/>
+          <p:nvPr/>
+        </p:nvSpPr>
+        <p:spPr>
+          <a:xfrm>
+            <a:off x="777240" y="5458968"/>
+            <a:ext cx="10744200" cy="777240"/>
+          </a:xfrm>
+          <a:prstGeom prst="rect">
+            <a:avLst/>
+          </a:prstGeom>
+          <a:noFill/>
+          <a:ln/>
+        </p:spPr>
+        <p:txBody>
+          <a:bodyPr wrap="square" rtlCol="0" anchor="ctr"/>
+          <a:lstStyle/>
+          <a:p>
+            <a:pPr indent="0" marL="0">
+              <a:buNone/>
+            </a:pPr>
+            <a:r>
+              <a:rPr lang="en-US" sz="1500" dirty="0">
+                <a:solidFill>
+                  <a:srgbClr val="1F2937"/>
+                </a:solidFill>
+                <a:latin typeface="Arial" pitchFamily="34" charset="0"/>
+                <a:ea typeface="Arial" pitchFamily="34" charset="-122"/>
+                <a:cs typeface="Arial" pitchFamily="34" charset="-120"/>
+              </a:rPr>
+              <a:t>Para tirar a empresa do papel, siga o plano dos noventa dias da tela: validar a conta, fechar a primeira usina e conquistar os primeiros clientes.</a:t>
+            </a:r>
+            <a:endParaRPr lang="en-US" sz="1500" dirty="0"/>
           </a:p>
         </p:txBody>
       </p:sp>
@@ -5837,11 +6009,11 @@
         <p:spPr>
           <a:xfrm>
             <a:off x="548640" y="1325880"/>
-            <a:ext cx="5431536" cy="2331720"/>
+            <a:ext cx="5431536" cy="1874520"/>
           </a:xfrm>
           <a:prstGeom prst="roundRect">
             <a:avLst>
-              <a:gd name="adj" fmla="val 3137"/>
+              <a:gd name="adj" fmla="val 3902"/>
             </a:avLst>
           </a:prstGeom>
           <a:solidFill>
@@ -5930,7 +6102,7 @@
         <p:spPr>
           <a:xfrm>
             <a:off x="1325880" y="1435608"/>
-            <a:ext cx="4517136" cy="2112264"/>
+            <a:ext cx="4517136" cy="1655064"/>
           </a:xfrm>
           <a:prstGeom prst="rect">
             <a:avLst/>
@@ -5971,11 +6143,11 @@
         <p:spPr>
           <a:xfrm>
             <a:off x="6208776" y="1325880"/>
-            <a:ext cx="5431536" cy="2331720"/>
+            <a:ext cx="5431536" cy="1874520"/>
           </a:xfrm>
           <a:prstGeom prst="roundRect">
             <a:avLst>
-              <a:gd name="adj" fmla="val 3137"/>
+              <a:gd name="adj" fmla="val 3902"/>
             </a:avLst>
           </a:prstGeom>
           <a:solidFill>
@@ -6064,7 +6236,7 @@
         <p:spPr>
           <a:xfrm>
             <a:off x="6986016" y="1435608"/>
-            <a:ext cx="4517136" cy="2112264"/>
+            <a:ext cx="4517136" cy="1655064"/>
           </a:xfrm>
           <a:prstGeom prst="rect">
             <a:avLst/>
@@ -6104,12 +6276,12 @@
         </p:nvSpPr>
         <p:spPr>
           <a:xfrm>
-            <a:off x="548640" y="3886200"/>
-            <a:ext cx="5431536" cy="2331720"/>
+            <a:off x="548640" y="3429000"/>
+            <a:ext cx="5431536" cy="1874520"/>
           </a:xfrm>
           <a:prstGeom prst="roundRect">
             <a:avLst>
-              <a:gd name="adj" fmla="val 3137"/>
+              <a:gd name="adj" fmla="val 3902"/>
             </a:avLst>
           </a:prstGeom>
           <a:solidFill>
@@ -6138,7 +6310,7 @@
         </p:nvSpPr>
         <p:spPr>
           <a:xfrm>
-            <a:off x="731520" y="4069080"/>
+            <a:off x="731520" y="3611880"/>
             <a:ext cx="457200" cy="457200"/>
           </a:xfrm>
           <a:prstGeom prst="ellipse">
@@ -6158,7 +6330,7 @@
         </p:nvSpPr>
         <p:spPr>
           <a:xfrm>
-            <a:off x="731520" y="4069080"/>
+            <a:off x="731520" y="3611880"/>
             <a:ext cx="457200" cy="457200"/>
           </a:xfrm>
           <a:prstGeom prst="rect">
@@ -6197,8 +6369,8 @@
         </p:nvSpPr>
         <p:spPr>
           <a:xfrm>
-            <a:off x="1325880" y="3995928"/>
-            <a:ext cx="4517136" cy="2112264"/>
+            <a:off x="1325880" y="3538728"/>
+            <a:ext cx="4517136" cy="1655064"/>
           </a:xfrm>
           <a:prstGeom prst="rect">
             <a:avLst/>
@@ -6238,12 +6410,12 @@
         </p:nvSpPr>
         <p:spPr>
           <a:xfrm>
-            <a:off x="6208776" y="3886200"/>
-            <a:ext cx="5431536" cy="2331720"/>
+            <a:off x="6208776" y="3429000"/>
+            <a:ext cx="5431536" cy="1874520"/>
           </a:xfrm>
           <a:prstGeom prst="roundRect">
             <a:avLst>
-              <a:gd name="adj" fmla="val 3137"/>
+              <a:gd name="adj" fmla="val 3902"/>
             </a:avLst>
           </a:prstGeom>
           <a:solidFill>
@@ -6272,7 +6444,7 @@
         </p:nvSpPr>
         <p:spPr>
           <a:xfrm>
-            <a:off x="6391656" y="4069080"/>
+            <a:off x="6391656" y="3611880"/>
             <a:ext cx="457200" cy="457200"/>
           </a:xfrm>
           <a:prstGeom prst="ellipse">
@@ -6292,7 +6464,7 @@
         </p:nvSpPr>
         <p:spPr>
           <a:xfrm>
-            <a:off x="6391656" y="4069080"/>
+            <a:off x="6391656" y="3611880"/>
             <a:ext cx="457200" cy="457200"/>
           </a:xfrm>
           <a:prstGeom prst="rect">
@@ -6331,8 +6503,8 @@
         </p:nvSpPr>
         <p:spPr>
           <a:xfrm>
-            <a:off x="6986016" y="3995928"/>
-            <a:ext cx="4517136" cy="2112264"/>
+            <a:off x="6986016" y="3538728"/>
+            <a:ext cx="4517136" cy="1655064"/>
           </a:xfrm>
           <a:prstGeom prst="rect">
             <a:avLst/>
@@ -6361,6 +6533,92 @@
               <a:t>implantação assistida</a:t>
             </a:r>
             <a:endParaRPr lang="en-US" sz="1800" dirty="0"/>
+          </a:p>
+        </p:txBody>
+      </p:sp>
+      <p:sp>
+        <p:nvSpPr>
+          <p:cNvPr id="25" name="Shape 22"/>
+          <p:cNvSpPr/>
+          <p:nvPr/>
+        </p:nvSpPr>
+        <p:spPr>
+          <a:xfrm>
+            <a:off x="548640" y="5413248"/>
+            <a:ext cx="11091672" cy="868680"/>
+          </a:xfrm>
+          <a:prstGeom prst="roundRect">
+            <a:avLst>
+              <a:gd name="adj" fmla="val 8421"/>
+            </a:avLst>
+          </a:prstGeom>
+          <a:solidFill>
+            <a:srgbClr val="EEF3FA"/>
+          </a:solidFill>
+          <a:ln w="6350">
+            <a:solidFill>
+              <a:srgbClr val="D8E0EC"/>
+            </a:solidFill>
+            <a:prstDash val="solid"/>
+          </a:ln>
+        </p:spPr>
+      </p:sp>
+      <p:sp>
+        <p:nvSpPr>
+          <p:cNvPr id="26" name="Shape 23"/>
+          <p:cNvSpPr/>
+          <p:nvPr/>
+        </p:nvSpPr>
+        <p:spPr>
+          <a:xfrm>
+            <a:off x="548640" y="5413248"/>
+            <a:ext cx="91440" cy="868680"/>
+          </a:xfrm>
+          <a:prstGeom prst="rect">
+            <a:avLst/>
+          </a:prstGeom>
+          <a:solidFill>
+            <a:srgbClr val="F7A23B"/>
+          </a:solidFill>
+          <a:ln/>
+        </p:spPr>
+      </p:sp>
+      <p:sp>
+        <p:nvSpPr>
+          <p:cNvPr id="27" name="Text 24"/>
+          <p:cNvSpPr/>
+          <p:nvPr/>
+        </p:nvSpPr>
+        <p:spPr>
+          <a:xfrm>
+            <a:off x="777240" y="5458968"/>
+            <a:ext cx="10744200" cy="777240"/>
+          </a:xfrm>
+          <a:prstGeom prst="rect">
+            <a:avLst/>
+          </a:prstGeom>
+          <a:noFill/>
+          <a:ln/>
+        </p:spPr>
+        <p:txBody>
+          <a:bodyPr wrap="square" rtlCol="0" anchor="ctr"/>
+          <a:lstStyle/>
+          <a:p>
+            <a:pPr indent="0" marL="0">
+              <a:buNone/>
+            </a:pPr>
+            <a:r>
+              <a:rPr lang="en-US" sz="1500" dirty="0">
+                <a:solidFill>
+                  <a:srgbClr val="1F2937"/>
+                </a:solidFill>
+                <a:latin typeface="Arial" pitchFamily="34" charset="0"/>
+                <a:ea typeface="Arial" pitchFamily="34" charset="-122"/>
+                <a:cs typeface="Arial" pitchFamily="34" charset="-120"/>
+              </a:rPr>
+              <a:t>Continue na comunidade e acompanhe as atualizações regulatórias.</a:t>
+            </a:r>
+            <a:endParaRPr lang="en-US" sz="1500" dirty="0"/>
           </a:p>
         </p:txBody>
       </p:sp>
@@ -7466,7 +7724,7 @@
         <p:spPr>
           <a:xfrm>
             <a:off x="548640" y="1325880"/>
-            <a:ext cx="5486400" cy="4937760"/>
+            <a:ext cx="5486400" cy="3977640"/>
           </a:xfrm>
           <a:prstGeom prst="rect">
             <a:avLst/>
@@ -7570,7 +7828,7 @@
         <p:spPr>
           <a:xfrm>
             <a:off x="6263640" y="1325880"/>
-            <a:ext cx="5486400" cy="4937760"/>
+            <a:ext cx="5486400" cy="3977640"/>
           </a:xfrm>
           <a:prstGeom prst="rect">
             <a:avLst/>
@@ -7642,6 +7900,92 @@
               <a:t>☐ Alertas críticos zerados no fechamento de cada mês</a:t>
             </a:r>
             <a:endParaRPr lang="en-US" sz="1800" dirty="0"/>
+          </a:p>
+        </p:txBody>
+      </p:sp>
+      <p:sp>
+        <p:nvSpPr>
+          <p:cNvPr id="11" name="Shape 8"/>
+          <p:cNvSpPr/>
+          <p:nvPr/>
+        </p:nvSpPr>
+        <p:spPr>
+          <a:xfrm>
+            <a:off x="548640" y="5413248"/>
+            <a:ext cx="11091672" cy="868680"/>
+          </a:xfrm>
+          <a:prstGeom prst="roundRect">
+            <a:avLst>
+              <a:gd name="adj" fmla="val 8421"/>
+            </a:avLst>
+          </a:prstGeom>
+          <a:solidFill>
+            <a:srgbClr val="EEF3FA"/>
+          </a:solidFill>
+          <a:ln w="6350">
+            <a:solidFill>
+              <a:srgbClr val="D8E0EC"/>
+            </a:solidFill>
+            <a:prstDash val="solid"/>
+          </a:ln>
+        </p:spPr>
+      </p:sp>
+      <p:sp>
+        <p:nvSpPr>
+          <p:cNvPr id="12" name="Shape 9"/>
+          <p:cNvSpPr/>
+          <p:nvPr/>
+        </p:nvSpPr>
+        <p:spPr>
+          <a:xfrm>
+            <a:off x="548640" y="5413248"/>
+            <a:ext cx="91440" cy="868680"/>
+          </a:xfrm>
+          <a:prstGeom prst="rect">
+            <a:avLst/>
+          </a:prstGeom>
+          <a:solidFill>
+            <a:srgbClr val="F7A23B"/>
+          </a:solidFill>
+          <a:ln/>
+        </p:spPr>
+      </p:sp>
+      <p:sp>
+        <p:nvSpPr>
+          <p:cNvPr id="13" name="Text 10"/>
+          <p:cNvSpPr/>
+          <p:nvPr/>
+        </p:nvSpPr>
+        <p:spPr>
+          <a:xfrm>
+            <a:off x="777240" y="5458968"/>
+            <a:ext cx="10744200" cy="777240"/>
+          </a:xfrm>
+          <a:prstGeom prst="rect">
+            <a:avLst/>
+          </a:prstGeom>
+          <a:noFill/>
+          <a:ln/>
+        </p:spPr>
+        <p:txBody>
+          <a:bodyPr wrap="square" rtlCol="0" anchor="ctr"/>
+          <a:lstStyle/>
+          <a:p>
+            <a:pPr indent="0" marL="0">
+              <a:buNone/>
+            </a:pPr>
+            <a:r>
+              <a:rPr lang="en-US" sz="1500" dirty="0">
+                <a:solidFill>
+                  <a:srgbClr val="1F2937"/>
+                </a:solidFill>
+                <a:latin typeface="Arial" pitchFamily="34" charset="0"/>
+                <a:ea typeface="Arial" pitchFamily="34" charset="-122"/>
+                <a:cs typeface="Arial" pitchFamily="34" charset="-120"/>
+              </a:rPr>
+              <a:t>No laboratório, a sua empresa precisa ter tudo o que está na lista da tela.</a:t>
+            </a:r>
+            <a:endParaRPr lang="en-US" sz="1500" dirty="0"/>
           </a:p>
         </p:txBody>
       </p:sp>
@@ -7961,11 +8305,11 @@
         <p:spPr>
           <a:xfrm>
             <a:off x="548640" y="1325880"/>
-            <a:ext cx="3544824" cy="2331720"/>
+            <a:ext cx="3544824" cy="1874520"/>
           </a:xfrm>
           <a:prstGeom prst="roundRect">
             <a:avLst>
-              <a:gd name="adj" fmla="val 3137"/>
+              <a:gd name="adj" fmla="val 3902"/>
             </a:avLst>
           </a:prstGeom>
           <a:solidFill>
@@ -8054,7 +8398,7 @@
         <p:spPr>
           <a:xfrm>
             <a:off x="1325880" y="1435608"/>
-            <a:ext cx="2630424" cy="2112264"/>
+            <a:ext cx="2630424" cy="1655064"/>
           </a:xfrm>
           <a:prstGeom prst="rect">
             <a:avLst/>
@@ -8095,11 +8439,11 @@
         <p:spPr>
           <a:xfrm>
             <a:off x="4322064" y="1325880"/>
-            <a:ext cx="3544824" cy="2331720"/>
+            <a:ext cx="3544824" cy="1874520"/>
           </a:xfrm>
           <a:prstGeom prst="roundRect">
             <a:avLst>
-              <a:gd name="adj" fmla="val 3137"/>
+              <a:gd name="adj" fmla="val 3902"/>
             </a:avLst>
           </a:prstGeom>
           <a:solidFill>
@@ -8188,7 +8532,7 @@
         <p:spPr>
           <a:xfrm>
             <a:off x="5099304" y="1435608"/>
-            <a:ext cx="2630424" cy="2112264"/>
+            <a:ext cx="2630424" cy="1655064"/>
           </a:xfrm>
           <a:prstGeom prst="rect">
             <a:avLst/>
@@ -8229,11 +8573,11 @@
         <p:spPr>
           <a:xfrm>
             <a:off x="8095488" y="1325880"/>
-            <a:ext cx="3544824" cy="2331720"/>
+            <a:ext cx="3544824" cy="1874520"/>
           </a:xfrm>
           <a:prstGeom prst="roundRect">
             <a:avLst>
-              <a:gd name="adj" fmla="val 3137"/>
+              <a:gd name="adj" fmla="val 3902"/>
             </a:avLst>
           </a:prstGeom>
           <a:solidFill>
@@ -8322,7 +8666,7 @@
         <p:spPr>
           <a:xfrm>
             <a:off x="8872728" y="1435608"/>
-            <a:ext cx="2630424" cy="2112264"/>
+            <a:ext cx="2630424" cy="1655064"/>
           </a:xfrm>
           <a:prstGeom prst="rect">
             <a:avLst/>
@@ -8362,12 +8706,12 @@
         </p:nvSpPr>
         <p:spPr>
           <a:xfrm>
-            <a:off x="548640" y="3886200"/>
-            <a:ext cx="3544824" cy="2331720"/>
+            <a:off x="548640" y="3429000"/>
+            <a:ext cx="3544824" cy="1874520"/>
           </a:xfrm>
           <a:prstGeom prst="roundRect">
             <a:avLst>
-              <a:gd name="adj" fmla="val 3137"/>
+              <a:gd name="adj" fmla="val 3902"/>
             </a:avLst>
           </a:prstGeom>
           <a:solidFill>
@@ -8396,7 +8740,7 @@
         </p:nvSpPr>
         <p:spPr>
           <a:xfrm>
-            <a:off x="731520" y="4069080"/>
+            <a:off x="731520" y="3611880"/>
             <a:ext cx="457200" cy="457200"/>
           </a:xfrm>
           <a:prstGeom prst="ellipse">
@@ -8416,7 +8760,7 @@
         </p:nvSpPr>
         <p:spPr>
           <a:xfrm>
-            <a:off x="731520" y="4069080"/>
+            <a:off x="731520" y="3611880"/>
             <a:ext cx="457200" cy="457200"/>
           </a:xfrm>
           <a:prstGeom prst="rect">
@@ -8455,8 +8799,8 @@
         </p:nvSpPr>
         <p:spPr>
           <a:xfrm>
-            <a:off x="1325880" y="3995928"/>
-            <a:ext cx="2630424" cy="2112264"/>
+            <a:off x="1325880" y="3538728"/>
+            <a:ext cx="2630424" cy="1655064"/>
           </a:xfrm>
           <a:prstGeom prst="rect">
             <a:avLst/>
@@ -8496,12 +8840,12 @@
         </p:nvSpPr>
         <p:spPr>
           <a:xfrm>
-            <a:off x="4322064" y="3886200"/>
-            <a:ext cx="3544824" cy="2331720"/>
+            <a:off x="4322064" y="3429000"/>
+            <a:ext cx="3544824" cy="1874520"/>
           </a:xfrm>
           <a:prstGeom prst="roundRect">
             <a:avLst>
-              <a:gd name="adj" fmla="val 3137"/>
+              <a:gd name="adj" fmla="val 3902"/>
             </a:avLst>
           </a:prstGeom>
           <a:solidFill>
@@ -8530,7 +8874,7 @@
         </p:nvSpPr>
         <p:spPr>
           <a:xfrm>
-            <a:off x="4504944" y="4069080"/>
+            <a:off x="4504944" y="3611880"/>
             <a:ext cx="457200" cy="457200"/>
           </a:xfrm>
           <a:prstGeom prst="ellipse">
@@ -8550,7 +8894,7 @@
         </p:nvSpPr>
         <p:spPr>
           <a:xfrm>
-            <a:off x="4504944" y="4069080"/>
+            <a:off x="4504944" y="3611880"/>
             <a:ext cx="457200" cy="457200"/>
           </a:xfrm>
           <a:prstGeom prst="rect">
@@ -8589,8 +8933,8 @@
         </p:nvSpPr>
         <p:spPr>
           <a:xfrm>
-            <a:off x="5099304" y="3995928"/>
-            <a:ext cx="2630424" cy="2112264"/>
+            <a:off x="5099304" y="3538728"/>
+            <a:ext cx="2630424" cy="1655064"/>
           </a:xfrm>
           <a:prstGeom prst="rect">
             <a:avLst/>
@@ -8630,12 +8974,12 @@
         </p:nvSpPr>
         <p:spPr>
           <a:xfrm>
-            <a:off x="8095488" y="3886200"/>
-            <a:ext cx="3544824" cy="2331720"/>
+            <a:off x="8095488" y="3429000"/>
+            <a:ext cx="3544824" cy="1874520"/>
           </a:xfrm>
           <a:prstGeom prst="roundRect">
             <a:avLst>
-              <a:gd name="adj" fmla="val 3137"/>
+              <a:gd name="adj" fmla="val 3902"/>
             </a:avLst>
           </a:prstGeom>
           <a:solidFill>
@@ -8664,7 +9008,7 @@
         </p:nvSpPr>
         <p:spPr>
           <a:xfrm>
-            <a:off x="8278368" y="4069080"/>
+            <a:off x="8278368" y="3611880"/>
             <a:ext cx="457200" cy="457200"/>
           </a:xfrm>
           <a:prstGeom prst="ellipse">
@@ -8684,7 +9028,7 @@
         </p:nvSpPr>
         <p:spPr>
           <a:xfrm>
-            <a:off x="8278368" y="4069080"/>
+            <a:off x="8278368" y="3611880"/>
             <a:ext cx="457200" cy="457200"/>
           </a:xfrm>
           <a:prstGeom prst="rect">
@@ -8723,8 +9067,8 @@
         </p:nvSpPr>
         <p:spPr>
           <a:xfrm>
-            <a:off x="8872728" y="3995928"/>
-            <a:ext cx="2630424" cy="2112264"/>
+            <a:off x="8872728" y="3538728"/>
+            <a:ext cx="2630424" cy="1655064"/>
           </a:xfrm>
           <a:prstGeom prst="rect">
             <a:avLst/>
@@ -8753,6 +9097,92 @@
               <a:t>Vídeo de até 5 minutos apresentando a empresa (opcional no autoestudo)</a:t>
             </a:r>
             <a:endParaRPr lang="en-US" sz="1800" dirty="0"/>
+          </a:p>
+        </p:txBody>
+      </p:sp>
+      <p:sp>
+        <p:nvSpPr>
+          <p:cNvPr id="33" name="Shape 30"/>
+          <p:cNvSpPr/>
+          <p:nvPr/>
+        </p:nvSpPr>
+        <p:spPr>
+          <a:xfrm>
+            <a:off x="548640" y="5413248"/>
+            <a:ext cx="11091672" cy="868680"/>
+          </a:xfrm>
+          <a:prstGeom prst="roundRect">
+            <a:avLst>
+              <a:gd name="adj" fmla="val 8421"/>
+            </a:avLst>
+          </a:prstGeom>
+          <a:solidFill>
+            <a:srgbClr val="EEF3FA"/>
+          </a:solidFill>
+          <a:ln w="6350">
+            <a:solidFill>
+              <a:srgbClr val="D8E0EC"/>
+            </a:solidFill>
+            <a:prstDash val="solid"/>
+          </a:ln>
+        </p:spPr>
+      </p:sp>
+      <p:sp>
+        <p:nvSpPr>
+          <p:cNvPr id="34" name="Shape 31"/>
+          <p:cNvSpPr/>
+          <p:nvPr/>
+        </p:nvSpPr>
+        <p:spPr>
+          <a:xfrm>
+            <a:off x="548640" y="5413248"/>
+            <a:ext cx="91440" cy="868680"/>
+          </a:xfrm>
+          <a:prstGeom prst="rect">
+            <a:avLst/>
+          </a:prstGeom>
+          <a:solidFill>
+            <a:srgbClr val="F7A23B"/>
+          </a:solidFill>
+          <a:ln/>
+        </p:spPr>
+      </p:sp>
+      <p:sp>
+        <p:nvSpPr>
+          <p:cNvPr id="35" name="Text 32"/>
+          <p:cNvSpPr/>
+          <p:nvPr/>
+        </p:nvSpPr>
+        <p:spPr>
+          <a:xfrm>
+            <a:off x="777240" y="5458968"/>
+            <a:ext cx="10744200" cy="777240"/>
+          </a:xfrm>
+          <a:prstGeom prst="rect">
+            <a:avLst/>
+          </a:prstGeom>
+          <a:noFill/>
+          <a:ln/>
+        </p:spPr>
+        <p:txBody>
+          <a:bodyPr wrap="square" rtlCol="0" anchor="ctr"/>
+          <a:lstStyle/>
+          <a:p>
+            <a:pPr indent="0" marL="0">
+              <a:buNone/>
+            </a:pPr>
+            <a:r>
+              <a:rPr lang="en-US" sz="1500" dirty="0">
+                <a:solidFill>
+                  <a:srgbClr val="1F2937"/>
+                </a:solidFill>
+                <a:latin typeface="Arial" pitchFamily="34" charset="0"/>
+                <a:ea typeface="Arial" pitchFamily="34" charset="-122"/>
+                <a:cs typeface="Arial" pitchFamily="34" charset="-120"/>
+              </a:rPr>
+              <a:t>Em documento, entregue os itens da tela.</a:t>
+            </a:r>
+            <a:endParaRPr lang="en-US" sz="1500" dirty="0"/>
           </a:p>
         </p:txBody>
       </p:sp>
@@ -9072,11 +9502,11 @@
         <p:spPr>
           <a:xfrm>
             <a:off x="548640" y="1325880"/>
-            <a:ext cx="5431536" cy="4892040"/>
+            <a:ext cx="5431536" cy="3977640"/>
           </a:xfrm>
           <a:prstGeom prst="roundRect">
             <a:avLst>
-              <a:gd name="adj" fmla="val 1495"/>
+              <a:gd name="adj" fmla="val 1839"/>
             </a:avLst>
           </a:prstGeom>
           <a:solidFill>
@@ -9165,7 +9595,7 @@
         <p:spPr>
           <a:xfrm>
             <a:off x="1325880" y="1435608"/>
-            <a:ext cx="4517136" cy="4672584"/>
+            <a:ext cx="4517136" cy="3758184"/>
           </a:xfrm>
           <a:prstGeom prst="rect">
             <a:avLst/>
@@ -9206,11 +9636,11 @@
         <p:spPr>
           <a:xfrm>
             <a:off x="6208776" y="1325880"/>
-            <a:ext cx="5431536" cy="4892040"/>
+            <a:ext cx="5431536" cy="3977640"/>
           </a:xfrm>
           <a:prstGeom prst="roundRect">
             <a:avLst>
-              <a:gd name="adj" fmla="val 1495"/>
+              <a:gd name="adj" fmla="val 1839"/>
             </a:avLst>
           </a:prstGeom>
           <a:solidFill>
@@ -9299,7 +9729,7 @@
         <p:spPr>
           <a:xfrm>
             <a:off x="6986016" y="1435608"/>
-            <a:ext cx="4517136" cy="4672584"/>
+            <a:ext cx="4517136" cy="3758184"/>
           </a:xfrm>
           <a:prstGeom prst="rect">
             <a:avLst/>
@@ -9328,6 +9758,92 @@
               <a:t>Semana 2: relatórios, documentos, vídeo, revisão pela rubrica</a:t>
             </a:r>
             <a:endParaRPr lang="en-US" sz="1800" dirty="0"/>
+          </a:p>
+        </p:txBody>
+      </p:sp>
+      <p:sp>
+        <p:nvSpPr>
+          <p:cNvPr id="17" name="Shape 14"/>
+          <p:cNvSpPr/>
+          <p:nvPr/>
+        </p:nvSpPr>
+        <p:spPr>
+          <a:xfrm>
+            <a:off x="548640" y="5413248"/>
+            <a:ext cx="11091672" cy="868680"/>
+          </a:xfrm>
+          <a:prstGeom prst="roundRect">
+            <a:avLst>
+              <a:gd name="adj" fmla="val 8421"/>
+            </a:avLst>
+          </a:prstGeom>
+          <a:solidFill>
+            <a:srgbClr val="EEF3FA"/>
+          </a:solidFill>
+          <a:ln w="6350">
+            <a:solidFill>
+              <a:srgbClr val="D8E0EC"/>
+            </a:solidFill>
+            <a:prstDash val="solid"/>
+          </a:ln>
+        </p:spPr>
+      </p:sp>
+      <p:sp>
+        <p:nvSpPr>
+          <p:cNvPr id="18" name="Shape 15"/>
+          <p:cNvSpPr/>
+          <p:nvPr/>
+        </p:nvSpPr>
+        <p:spPr>
+          <a:xfrm>
+            <a:off x="548640" y="5413248"/>
+            <a:ext cx="91440" cy="868680"/>
+          </a:xfrm>
+          <a:prstGeom prst="rect">
+            <a:avLst/>
+          </a:prstGeom>
+          <a:solidFill>
+            <a:srgbClr val="F7A23B"/>
+          </a:solidFill>
+          <a:ln/>
+        </p:spPr>
+      </p:sp>
+      <p:sp>
+        <p:nvSpPr>
+          <p:cNvPr id="19" name="Text 16"/>
+          <p:cNvSpPr/>
+          <p:nvPr/>
+        </p:nvSpPr>
+        <p:spPr>
+          <a:xfrm>
+            <a:off x="777240" y="5458968"/>
+            <a:ext cx="10744200" cy="777240"/>
+          </a:xfrm>
+          <a:prstGeom prst="rect">
+            <a:avLst/>
+          </a:prstGeom>
+          <a:noFill/>
+          <a:ln/>
+        </p:spPr>
+        <p:txBody>
+          <a:bodyPr wrap="square" rtlCol="0" anchor="ctr"/>
+          <a:lstStyle/>
+          <a:p>
+            <a:pPr indent="0" marL="0">
+              <a:buNone/>
+            </a:pPr>
+            <a:r>
+              <a:rPr lang="en-US" sz="1500" dirty="0">
+                <a:solidFill>
+                  <a:srgbClr val="1F2937"/>
+                </a:solidFill>
+                <a:latin typeface="Arial" pitchFamily="34" charset="0"/>
+                <a:ea typeface="Arial" pitchFamily="34" charset="-122"/>
+                <a:cs typeface="Arial" pitchFamily="34" charset="-120"/>
+              </a:rPr>
+              <a:t>Organize em duas semanas: primeiro o laboratório, depois os documentos e a revisão pela rubrica.</a:t>
+            </a:r>
+            <a:endParaRPr lang="en-US" sz="1500" dirty="0"/>
           </a:p>
         </p:txBody>
       </p:sp>
@@ -10026,7 +10542,7 @@
         </p:nvGraphicFramePr>
         <p:xfrm>
           <a:off x="548640" y="1325880"/>
-          <a:ext cx="5669280" cy="4937760"/>
+          <a:ext cx="5669280" cy="3977640"/>
         </p:xfrm>
         <a:graphic xmlns:a="http://schemas.openxmlformats.org/drawingml/2006/main">
           <a:graphicData uri="http://schemas.openxmlformats.org/drawingml/2006/chart">
@@ -10049,7 +10565,7 @@
           </p:nvPr>
         </p:nvGraphicFramePr>
         <p:xfrm>
-          <a:off x="6446520" y="1600200"/>
+          <a:off x="6446520" y="1508760"/>
           <a:ext cx="5193792" cy="914400"/>
         </p:xfrm>
         <a:graphic>
@@ -10894,6 +11410,92 @@
       </p:graphicFrame>
       <p:sp>
         <p:nvSpPr>
+          <p:cNvPr id="11" name="Shape 6"/>
+          <p:cNvSpPr/>
+          <p:nvPr/>
+        </p:nvSpPr>
+        <p:spPr>
+          <a:xfrm>
+            <a:off x="548640" y="5413248"/>
+            <a:ext cx="11091672" cy="868680"/>
+          </a:xfrm>
+          <a:prstGeom prst="roundRect">
+            <a:avLst>
+              <a:gd name="adj" fmla="val 8421"/>
+            </a:avLst>
+          </a:prstGeom>
+          <a:solidFill>
+            <a:srgbClr val="EEF3FA"/>
+          </a:solidFill>
+          <a:ln w="6350">
+            <a:solidFill>
+              <a:srgbClr val="D8E0EC"/>
+            </a:solidFill>
+            <a:prstDash val="solid"/>
+          </a:ln>
+        </p:spPr>
+      </p:sp>
+      <p:sp>
+        <p:nvSpPr>
+          <p:cNvPr id="12" name="Shape 7"/>
+          <p:cNvSpPr/>
+          <p:nvPr/>
+        </p:nvSpPr>
+        <p:spPr>
+          <a:xfrm>
+            <a:off x="548640" y="5413248"/>
+            <a:ext cx="91440" cy="868680"/>
+          </a:xfrm>
+          <a:prstGeom prst="rect">
+            <a:avLst/>
+          </a:prstGeom>
+          <a:solidFill>
+            <a:srgbClr val="F7A23B"/>
+          </a:solidFill>
+          <a:ln/>
+        </p:spPr>
+      </p:sp>
+      <p:sp>
+        <p:nvSpPr>
+          <p:cNvPr id="13" name="Text 8"/>
+          <p:cNvSpPr/>
+          <p:nvPr/>
+        </p:nvSpPr>
+        <p:spPr>
+          <a:xfrm>
+            <a:off x="777240" y="5458968"/>
+            <a:ext cx="10744200" cy="777240"/>
+          </a:xfrm>
+          <a:prstGeom prst="rect">
+            <a:avLst/>
+          </a:prstGeom>
+          <a:noFill/>
+          <a:ln/>
+        </p:spPr>
+        <p:txBody>
+          <a:bodyPr wrap="square" rtlCol="0" anchor="ctr"/>
+          <a:lstStyle/>
+          <a:p>
+            <a:pPr indent="0" marL="0">
+              <a:buNone/>
+            </a:pPr>
+            <a:r>
+              <a:rPr lang="en-US" sz="1500" dirty="0">
+                <a:solidFill>
+                  <a:srgbClr val="1F2937"/>
+                </a:solidFill>
+                <a:latin typeface="Arial" pitchFamily="34" charset="0"/>
+                <a:ea typeface="Arial" pitchFamily="34" charset="-122"/>
+                <a:cs typeface="Arial" pitchFamily="34" charset="-120"/>
+              </a:rPr>
+              <a:t>O maior peso é a operação no laboratório. Nos documentos, vale a coerência dos números, a análise e a linguagem correta.</a:t>
+            </a:r>
+            <a:endParaRPr lang="en-US" sz="1500" dirty="0"/>
+          </a:p>
+        </p:txBody>
+      </p:sp>
+      <p:sp>
+        <p:nvSpPr>
           <p:cNvPr id="25" name="Slide Number Placeholder 0"/>
           <p:cNvSpPr>
             <a:spLocks noGrp="1"/>
@@ -11208,7 +11810,7 @@
         <p:spPr>
           <a:xfrm>
             <a:off x="548640" y="1325880"/>
-            <a:ext cx="3544824" cy="4892040"/>
+            <a:ext cx="3544824" cy="3977640"/>
           </a:xfrm>
           <a:prstGeom prst="roundRect">
             <a:avLst>
@@ -11301,7 +11903,7 @@
         <p:spPr>
           <a:xfrm>
             <a:off x="1325880" y="1435608"/>
-            <a:ext cx="2630424" cy="4672584"/>
+            <a:ext cx="2630424" cy="3758184"/>
           </a:xfrm>
           <a:prstGeom prst="rect">
             <a:avLst/>
@@ -11342,7 +11944,7 @@
         <p:spPr>
           <a:xfrm>
             <a:off x="4322064" y="1325880"/>
-            <a:ext cx="3544824" cy="4892040"/>
+            <a:ext cx="3544824" cy="3977640"/>
           </a:xfrm>
           <a:prstGeom prst="roundRect">
             <a:avLst>
@@ -11435,7 +12037,7 @@
         <p:spPr>
           <a:xfrm>
             <a:off x="5099304" y="1435608"/>
-            <a:ext cx="2630424" cy="4672584"/>
+            <a:ext cx="2630424" cy="3758184"/>
           </a:xfrm>
           <a:prstGeom prst="rect">
             <a:avLst/>
@@ -11476,7 +12078,7 @@
         <p:spPr>
           <a:xfrm>
             <a:off x="8095488" y="1325880"/>
-            <a:ext cx="3544824" cy="4892040"/>
+            <a:ext cx="3544824" cy="3977640"/>
           </a:xfrm>
           <a:prstGeom prst="roundRect">
             <a:avLst>
@@ -11569,7 +12171,7 @@
         <p:spPr>
           <a:xfrm>
             <a:off x="8872728" y="1435608"/>
-            <a:ext cx="2630424" cy="4672584"/>
+            <a:ext cx="2630424" cy="3758184"/>
           </a:xfrm>
           <a:prstGeom prst="rect">
             <a:avLst/>
@@ -11598,6 +12200,92 @@
               <a:t>abaixo de 70%: devolutiva e uma nova entrega</a:t>
             </a:r>
             <a:endParaRPr lang="en-US" sz="1800" dirty="0"/>
+          </a:p>
+        </p:txBody>
+      </p:sp>
+      <p:sp>
+        <p:nvSpPr>
+          <p:cNvPr id="21" name="Shape 18"/>
+          <p:cNvSpPr/>
+          <p:nvPr/>
+        </p:nvSpPr>
+        <p:spPr>
+          <a:xfrm>
+            <a:off x="548640" y="5413248"/>
+            <a:ext cx="11091672" cy="868680"/>
+          </a:xfrm>
+          <a:prstGeom prst="roundRect">
+            <a:avLst>
+              <a:gd name="adj" fmla="val 8421"/>
+            </a:avLst>
+          </a:prstGeom>
+          <a:solidFill>
+            <a:srgbClr val="EEF3FA"/>
+          </a:solidFill>
+          <a:ln w="6350">
+            <a:solidFill>
+              <a:srgbClr val="D8E0EC"/>
+            </a:solidFill>
+            <a:prstDash val="solid"/>
+          </a:ln>
+        </p:spPr>
+      </p:sp>
+      <p:sp>
+        <p:nvSpPr>
+          <p:cNvPr id="22" name="Shape 19"/>
+          <p:cNvSpPr/>
+          <p:nvPr/>
+        </p:nvSpPr>
+        <p:spPr>
+          <a:xfrm>
+            <a:off x="548640" y="5413248"/>
+            <a:ext cx="91440" cy="868680"/>
+          </a:xfrm>
+          <a:prstGeom prst="rect">
+            <a:avLst/>
+          </a:prstGeom>
+          <a:solidFill>
+            <a:srgbClr val="F7A23B"/>
+          </a:solidFill>
+          <a:ln/>
+        </p:spPr>
+      </p:sp>
+      <p:sp>
+        <p:nvSpPr>
+          <p:cNvPr id="23" name="Text 20"/>
+          <p:cNvSpPr/>
+          <p:nvPr/>
+        </p:nvSpPr>
+        <p:spPr>
+          <a:xfrm>
+            <a:off x="777240" y="5458968"/>
+            <a:ext cx="10744200" cy="777240"/>
+          </a:xfrm>
+          <a:prstGeom prst="rect">
+            <a:avLst/>
+          </a:prstGeom>
+          <a:noFill/>
+          <a:ln/>
+        </p:spPr>
+        <p:txBody>
+          <a:bodyPr wrap="square" rtlCol="0" anchor="ctr"/>
+          <a:lstStyle/>
+          <a:p>
+            <a:pPr indent="0" marL="0">
+              <a:buNone/>
+            </a:pPr>
+            <a:r>
+              <a:rPr lang="en-US" sz="1500" dirty="0">
+                <a:solidFill>
+                  <a:srgbClr val="1F2937"/>
+                </a:solidFill>
+                <a:latin typeface="Arial" pitchFamily="34" charset="0"/>
+                <a:ea typeface="Arial" pitchFamily="34" charset="-122"/>
+                <a:cs typeface="Arial" pitchFamily="34" charset="-120"/>
+              </a:rPr>
+              <a:t>Setenta por cento aprova; noventa, com distinção.</a:t>
+            </a:r>
+            <a:endParaRPr lang="en-US" sz="1500" dirty="0"/>
           </a:p>
         </p:txBody>
       </p:sp>

</xml_diff>